<commit_message>
Add 3-agent pipeline: Validator, Classifier, Anomaly Detector
- Validator Agent: uses Groq LLM to decide which CAMARA APIs to call
  based on report context (urgency, coordinates, language)
- Classifier Agent: uses Groq LLM to classify incident type, severity,
  sector with reasoning trace
- Anomaly Detector: Haversine spatial clustering + LLM pattern detection
- IncidentPipeline: wires all 3 agents into end-to-end flow
- All tested: report in -> 3 CAMARA API calls -> classified -> anomaly checked
- Uses openai/gpt-oss-120b on Groq (approved tool from Resource Guide)
</commit_message>
<xml_diff>
--- a/docs/SENTINEL Pitch Deck.pptx
+++ b/docs/SENTINEL Pitch Deck.pptx
@@ -4250,7 +4250,7 @@
         <p:spPr>
           <a:xfrm>
             <a:off x="2331720" y="2788920"/>
-            <a:ext cx="411480" cy="731520"/>
+            <a:ext cx="512064" cy="731520"/>
           </a:xfrm>
           <a:prstGeom prst="rect">
             <a:avLst/>
@@ -4428,7 +4428,7 @@
         <p:spPr>
           <a:xfrm>
             <a:off x="4572000" y="2788920"/>
-            <a:ext cx="411480" cy="731520"/>
+            <a:ext cx="557784" cy="731520"/>
           </a:xfrm>
           <a:prstGeom prst="rect">
             <a:avLst/>
@@ -4606,7 +4606,7 @@
         <p:spPr>
           <a:xfrm>
             <a:off x="6812280" y="2788920"/>
-            <a:ext cx="411480" cy="731520"/>
+            <a:ext cx="512064" cy="731520"/>
           </a:xfrm>
           <a:prstGeom prst="rect">
             <a:avLst/>
@@ -4784,7 +4784,7 @@
         <p:spPr>
           <a:xfrm>
             <a:off x="9052560" y="2788920"/>
-            <a:ext cx="411480" cy="731520"/>
+            <a:ext cx="512064" cy="731520"/>
           </a:xfrm>
           <a:prstGeom prst="rect">
             <a:avLst/>

</xml_diff>